<commit_message>
docs: rename project to LightMap Boston, update plan and slide
</commit_message>
<xml_diff>
--- a/docs/slide-overview.pptx
+++ b/docs/slide-overview.pptx
@@ -3104,8 +3104,8 @@
         </p:nvSpPr>
         <p:spPr>
           <a:xfrm>
-            <a:off x="822960" y="411480"/>
-            <a:ext cx="3657600" cy="411480"/>
+            <a:off x="731520" y="365760"/>
+            <a:ext cx="4572000" cy="320040"/>
           </a:xfrm>
           <a:prstGeom prst="rect">
             <a:avLst/>
@@ -3119,89 +3119,35 @@
           <a:lstStyle/>
           <a:p>
             <a:pPr algn="l">
-              <a:defRPr sz="1600" b="1" i="0">
-                <a:solidFill>
-                  <a:srgbClr val="94A3B8"/>
+              <a:defRPr sz="1600" b="1">
+                <a:solidFill>
+                  <a:srgbClr val="F59E0B"/>
                 </a:solidFill>
                 <a:latin typeface="Calibri"/>
               </a:defRPr>
             </a:pPr>
             <a:r>
-              <a:t>SafeRoute Boston</a:t>
-            </a:r>
-          </a:p>
-        </p:txBody>
-      </p:sp>
-      <p:sp>
-        <p:nvSpPr>
-          <p:cNvPr id="3" name="TextBox 2"/>
-          <p:cNvSpPr txBox="1"/>
+              <a:t>LightMap Boston</a:t>
+            </a:r>
+          </a:p>
+        </p:txBody>
+      </p:sp>
+      <p:sp>
+        <p:nvSpPr>
+          <p:cNvPr id="3" name="Rectangle 2"/>
+          <p:cNvSpPr/>
           <p:nvPr/>
         </p:nvSpPr>
         <p:spPr>
           <a:xfrm>
-            <a:off x="822960" y="1188720"/>
-            <a:ext cx="10545775" cy="1005840"/>
+            <a:off x="731520" y="713232"/>
+            <a:ext cx="1188720" cy="18288"/>
           </a:xfrm>
           <a:prstGeom prst="rect">
             <a:avLst/>
           </a:prstGeom>
-          <a:noFill/>
-        </p:spPr>
-        <p:txBody>
-          <a:bodyPr wrap="square">
-            <a:spAutoFit/>
-          </a:bodyPr>
-          <a:lstStyle/>
-          <a:p>
-            <a:pPr algn="ctr">
-              <a:spcAft>
-                <a:spcPts val="600"/>
-              </a:spcAft>
-              <a:defRPr sz="3000" b="0">
-                <a:solidFill>
-                  <a:srgbClr val="FFFFFF"/>
-                </a:solidFill>
-                <a:latin typeface="Calibri"/>
-              </a:defRPr>
-            </a:pPr>
-            <a:r>
-              <a:t>Every map finds the fastest path.</a:t>
-            </a:r>
-          </a:p>
-          <a:p>
-            <a:pPr algn="ctr">
-              <a:defRPr sz="3000" b="1">
-                <a:solidFill>
-                  <a:srgbClr val="F59E0B"/>
-                </a:solidFill>
-                <a:latin typeface="Calibri"/>
-              </a:defRPr>
-            </a:pPr>
-            <a:r>
-              <a:t>No map finds the path that protects you.</a:t>
-            </a:r>
-          </a:p>
-        </p:txBody>
-      </p:sp>
-      <p:sp>
-        <p:nvSpPr>
-          <p:cNvPr id="4" name="Rounded Rectangle 3"/>
-          <p:cNvSpPr/>
-          <p:nvPr/>
-        </p:nvSpPr>
-        <p:spPr>
-          <a:xfrm>
-            <a:off x="3444087" y="2331720"/>
-            <a:ext cx="5303520" cy="502920"/>
-          </a:xfrm>
-          <a:prstGeom prst="roundRect">
-            <a:avLst>
-              <a:gd name="adj" fmla="val 15000"/>
-            </a:avLst>
-          </a:prstGeom>
           <a:solidFill>
-            <a:srgbClr val="1A243B"/>
+            <a:srgbClr val="F59E0B"/>
           </a:solidFill>
           <a:ln>
             <a:noFill/>
@@ -3222,82 +3168,137 @@
           </a:fontRef>
         </p:style>
         <p:txBody>
-          <a:bodyPr rtlCol="0" anchor="ctr" wrap="square"/>
-          <a:lstStyle/>
-          <a:p>
-            <a:pPr algn="ctr">
-              <a:spcBef>
-                <a:spcPts val="0"/>
-              </a:spcBef>
-              <a:spcAft>
-                <a:spcPts val="0"/>
-              </a:spcAft>
-              <a:defRPr sz="2200" b="0">
-                <a:solidFill>
-                  <a:srgbClr val="D9972B"/>
-                </a:solidFill>
-                <a:latin typeface="Calibri"/>
-              </a:defRPr>
-            </a:pPr>
-            <a:r>
-              <a:t>"Right now, from here, which way?"</a:t>
-            </a:r>
-          </a:p>
-        </p:txBody>
-      </p:sp>
-      <p:cxnSp>
-        <p:nvCxnSpPr>
-          <p:cNvPr id="5" name="Connector 4"/>
-          <p:cNvCxnSpPr/>
+          <a:bodyPr rtlCol="0" anchor="ctr"/>
+          <a:lstStyle/>
+          <a:p>
+            <a:pPr algn="ctr"/>
+          </a:p>
+        </p:txBody>
+      </p:sp>
+      <p:sp>
+        <p:nvSpPr>
+          <p:cNvPr id="4" name="TextBox 3"/>
+          <p:cNvSpPr txBox="1"/>
           <p:nvPr/>
-        </p:nvCxnSpPr>
-        <p:spPr>
-          <a:xfrm>
-            <a:off x="3200400" y="3246120"/>
-            <a:ext cx="5790895" cy="0"/>
-          </a:xfrm>
-          <a:prstGeom prst="line">
+        </p:nvSpPr>
+        <p:spPr>
+          <a:xfrm>
+            <a:off x="731520" y="1097280"/>
+            <a:ext cx="10698480" cy="457200"/>
+          </a:xfrm>
+          <a:prstGeom prst="rect">
             <a:avLst/>
           </a:prstGeom>
-          <a:ln w="12700">
-            <a:solidFill>
-              <a:srgbClr val="1E293B"/>
-            </a:solidFill>
-          </a:ln>
-        </p:spPr>
-        <p:style>
-          <a:lnRef idx="2">
-            <a:schemeClr val="accent1"/>
-          </a:lnRef>
-          <a:fillRef idx="0">
-            <a:schemeClr val="accent1"/>
-          </a:fillRef>
-          <a:effectRef idx="1">
-            <a:schemeClr val="accent1"/>
-          </a:effectRef>
-          <a:fontRef idx="minor">
-            <a:schemeClr val="tx1"/>
-          </a:fontRef>
-        </p:style>
-      </p:cxnSp>
-      <p:sp>
-        <p:nvSpPr>
-          <p:cNvPr id="6" name="Rounded Rectangle 5"/>
+          <a:noFill/>
+        </p:spPr>
+        <p:txBody>
+          <a:bodyPr wrap="square">
+            <a:spAutoFit/>
+          </a:bodyPr>
+          <a:lstStyle/>
+          <a:p>
+            <a:pPr algn="l">
+              <a:defRPr sz="3400" b="1">
+                <a:solidFill>
+                  <a:srgbClr val="FBBF24"/>
+                </a:solidFill>
+                <a:latin typeface="Calibri"/>
+              </a:defRPr>
+            </a:pPr>
+            <a:r>
+              <a:t>Daytime — where is the shade?</a:t>
+            </a:r>
+          </a:p>
+        </p:txBody>
+      </p:sp>
+      <p:sp>
+        <p:nvSpPr>
+          <p:cNvPr id="5" name="TextBox 4"/>
+          <p:cNvSpPr txBox="1"/>
+          <p:nvPr/>
+        </p:nvSpPr>
+        <p:spPr>
+          <a:xfrm>
+            <a:off x="731520" y="1645920"/>
+            <a:ext cx="10698480" cy="457200"/>
+          </a:xfrm>
+          <a:prstGeom prst="rect">
+            <a:avLst/>
+          </a:prstGeom>
+          <a:noFill/>
+        </p:spPr>
+        <p:txBody>
+          <a:bodyPr wrap="square">
+            <a:spAutoFit/>
+          </a:bodyPr>
+          <a:lstStyle/>
+          <a:p>
+            <a:pPr algn="l">
+              <a:defRPr sz="3400" b="1">
+                <a:solidFill>
+                  <a:srgbClr val="60A5FA"/>
+                </a:solidFill>
+                <a:latin typeface="Calibri"/>
+              </a:defRPr>
+            </a:pPr>
+            <a:r>
+              <a:t>Nighttime — where is the light?</a:t>
+            </a:r>
+          </a:p>
+        </p:txBody>
+      </p:sp>
+      <p:sp>
+        <p:nvSpPr>
+          <p:cNvPr id="6" name="TextBox 5"/>
+          <p:cNvSpPr txBox="1"/>
+          <p:nvPr/>
+        </p:nvSpPr>
+        <p:spPr>
+          <a:xfrm>
+            <a:off x="731520" y="2377440"/>
+            <a:ext cx="10698480" cy="320040"/>
+          </a:xfrm>
+          <a:prstGeom prst="rect">
+            <a:avLst/>
+          </a:prstGeom>
+          <a:noFill/>
+        </p:spPr>
+        <p:txBody>
+          <a:bodyPr wrap="square">
+            <a:spAutoFit/>
+          </a:bodyPr>
+          <a:lstStyle/>
+          <a:p>
+            <a:pPr algn="l">
+              <a:defRPr sz="1600" b="0">
+                <a:solidFill>
+                  <a:srgbClr val="CBD5E1"/>
+                </a:solidFill>
+                <a:latin typeface="Calibri"/>
+              </a:defRPr>
+            </a:pPr>
+            <a:r>
+              <a:t>A real-time map of Boston that shows shaded and bright areas as the sun moves and the city lights up.</a:t>
+            </a:r>
+          </a:p>
+        </p:txBody>
+      </p:sp>
+      <p:sp>
+        <p:nvSpPr>
+          <p:cNvPr id="7" name="Rectangle 6"/>
           <p:cNvSpPr/>
           <p:nvPr/>
         </p:nvSpPr>
         <p:spPr>
           <a:xfrm>
-            <a:off x="1912467" y="3520440"/>
-            <a:ext cx="1920240" cy="457200"/>
-          </a:xfrm>
-          <a:prstGeom prst="roundRect">
-            <a:avLst>
-              <a:gd name="adj" fmla="val 15000"/>
-            </a:avLst>
+            <a:off x="731520" y="2926080"/>
+            <a:ext cx="10698480" cy="18288"/>
+          </a:xfrm>
+          <a:prstGeom prst="rect">
+            <a:avLst/>
           </a:prstGeom>
           <a:solidFill>
-            <a:srgbClr val="172033"/>
+            <a:srgbClr val="475569"/>
           </a:solidFill>
           <a:ln>
             <a:noFill/>
@@ -3322,45 +3323,25 @@
           <a:lstStyle/>
           <a:p>
             <a:pPr algn="ctr"/>
-            <a:r>
-              <a:rPr sz="1300" b="1">
-                <a:solidFill>
-                  <a:srgbClr val="FFFFFF"/>
-                </a:solidFill>
-                <a:latin typeface="Calibri"/>
-              </a:rPr>
-              <a:t>Shade</a:t>
-            </a:r>
-            <a:r>
-              <a:rPr sz="1000" b="0">
-                <a:solidFill>
-                  <a:srgbClr val="64748B"/>
-                </a:solidFill>
-                <a:latin typeface="Calibri"/>
-              </a:rPr>
-              <a:t>  Sun protection</a:t>
-            </a:r>
-          </a:p>
-        </p:txBody>
-      </p:sp>
-      <p:sp>
-        <p:nvSpPr>
-          <p:cNvPr id="7" name="Rounded Rectangle 6"/>
+          </a:p>
+        </p:txBody>
+      </p:sp>
+      <p:sp>
+        <p:nvSpPr>
+          <p:cNvPr id="8" name="Rounded Rectangle 7"/>
           <p:cNvSpPr/>
           <p:nvPr/>
         </p:nvSpPr>
         <p:spPr>
           <a:xfrm>
-            <a:off x="4061307" y="3520440"/>
-            <a:ext cx="1920240" cy="457200"/>
+            <a:off x="792327" y="3200400"/>
+            <a:ext cx="2377440" cy="1554480"/>
           </a:xfrm>
           <a:prstGeom prst="roundRect">
-            <a:avLst>
-              <a:gd name="adj" fmla="val 15000"/>
-            </a:avLst>
+            <a:avLst/>
           </a:prstGeom>
           <a:solidFill>
-            <a:srgbClr val="172033"/>
+            <a:srgbClr val="162134"/>
           </a:solidFill>
           <a:ln>
             <a:noFill/>
@@ -3385,45 +3366,173 @@
           <a:lstStyle/>
           <a:p>
             <a:pPr algn="ctr"/>
-            <a:r>
-              <a:rPr sz="1300" b="1">
-                <a:solidFill>
-                  <a:srgbClr val="FFFFFF"/>
+          </a:p>
+        </p:txBody>
+      </p:sp>
+      <p:sp>
+        <p:nvSpPr>
+          <p:cNvPr id="9" name="TextBox 8"/>
+          <p:cNvSpPr txBox="1"/>
+          <p:nvPr/>
+        </p:nvSpPr>
+        <p:spPr>
+          <a:xfrm>
+            <a:off x="792327" y="3246120"/>
+            <a:ext cx="2377440" cy="411480"/>
+          </a:xfrm>
+          <a:prstGeom prst="rect">
+            <a:avLst/>
+          </a:prstGeom>
+          <a:noFill/>
+        </p:spPr>
+        <p:txBody>
+          <a:bodyPr wrap="square">
+            <a:spAutoFit/>
+          </a:bodyPr>
+          <a:lstStyle/>
+          <a:p>
+            <a:pPr algn="ctr">
+              <a:defRPr sz="3000" b="0">
+                <a:solidFill>
+                  <a:srgbClr val="F1F5F9"/>
                 </a:solidFill>
                 <a:latin typeface="Calibri"/>
-              </a:rPr>
-              <a:t>Light</a:t>
-            </a:r>
-            <a:r>
-              <a:rPr sz="1000" b="0">
-                <a:solidFill>
-                  <a:srgbClr val="64748B"/>
+              </a:defRPr>
+            </a:pPr>
+            <a:r>
+              <a:t>☀️</a:t>
+            </a:r>
+          </a:p>
+        </p:txBody>
+      </p:sp>
+      <p:sp>
+        <p:nvSpPr>
+          <p:cNvPr id="10" name="TextBox 9"/>
+          <p:cNvSpPr txBox="1"/>
+          <p:nvPr/>
+        </p:nvSpPr>
+        <p:spPr>
+          <a:xfrm>
+            <a:off x="792327" y="3657600"/>
+            <a:ext cx="2377440" cy="274320"/>
+          </a:xfrm>
+          <a:prstGeom prst="rect">
+            <a:avLst/>
+          </a:prstGeom>
+          <a:noFill/>
+        </p:spPr>
+        <p:txBody>
+          <a:bodyPr wrap="square">
+            <a:spAutoFit/>
+          </a:bodyPr>
+          <a:lstStyle/>
+          <a:p>
+            <a:pPr algn="ctr">
+              <a:defRPr sz="1400" b="1">
+                <a:solidFill>
+                  <a:srgbClr val="FBBF24"/>
                 </a:solidFill>
                 <a:latin typeface="Calibri"/>
-              </a:rPr>
-              <a:t>  Night visibility</a:t>
-            </a:r>
-          </a:p>
-        </p:txBody>
-      </p:sp>
-      <p:sp>
-        <p:nvSpPr>
-          <p:cNvPr id="8" name="Rounded Rectangle 7"/>
+              </a:defRPr>
+            </a:pPr>
+            <a:r>
+              <a:t>Shade Map</a:t>
+            </a:r>
+          </a:p>
+        </p:txBody>
+      </p:sp>
+      <p:sp>
+        <p:nvSpPr>
+          <p:cNvPr id="11" name="TextBox 10"/>
+          <p:cNvSpPr txBox="1"/>
+          <p:nvPr/>
+        </p:nvSpPr>
+        <p:spPr>
+          <a:xfrm>
+            <a:off x="792327" y="3977639"/>
+            <a:ext cx="2377440" cy="411480"/>
+          </a:xfrm>
+          <a:prstGeom prst="rect">
+            <a:avLst/>
+          </a:prstGeom>
+          <a:noFill/>
+        </p:spPr>
+        <p:txBody>
+          <a:bodyPr wrap="square">
+            <a:spAutoFit/>
+          </a:bodyPr>
+          <a:lstStyle/>
+          <a:p>
+            <a:pPr algn="ctr">
+              <a:defRPr sz="1100" b="0">
+                <a:solidFill>
+                  <a:srgbClr val="CBD5E1"/>
+                </a:solidFill>
+                <a:latin typeface="Calibri"/>
+              </a:defRPr>
+            </a:pPr>
+            <a:r>
+              <a:t>Safe from sunburn</a:t>
+            </a:r>
+            <a:br/>
+            <a:r>
+              <a:t>and heatstroke</a:t>
+            </a:r>
+          </a:p>
+        </p:txBody>
+      </p:sp>
+      <p:sp>
+        <p:nvSpPr>
+          <p:cNvPr id="12" name="TextBox 11"/>
+          <p:cNvSpPr txBox="1"/>
+          <p:nvPr/>
+        </p:nvSpPr>
+        <p:spPr>
+          <a:xfrm>
+            <a:off x="792327" y="4389120"/>
+            <a:ext cx="2377440" cy="274320"/>
+          </a:xfrm>
+          <a:prstGeom prst="rect">
+            <a:avLst/>
+          </a:prstGeom>
+          <a:noFill/>
+        </p:spPr>
+        <p:txBody>
+          <a:bodyPr wrap="square">
+            <a:spAutoFit/>
+          </a:bodyPr>
+          <a:lstStyle/>
+          <a:p>
+            <a:pPr algn="ctr">
+              <a:defRPr sz="900" b="0">
+                <a:solidFill>
+                  <a:srgbClr val="475569"/>
+                </a:solidFill>
+                <a:latin typeface="Calibri"/>
+              </a:defRPr>
+            </a:pPr>
+            <a:r>
+              <a:t>Sun angle × 128K buildings</a:t>
+            </a:r>
+          </a:p>
+        </p:txBody>
+      </p:sp>
+      <p:sp>
+        <p:nvSpPr>
+          <p:cNvPr id="13" name="Rounded Rectangle 12"/>
           <p:cNvSpPr/>
           <p:nvPr/>
         </p:nvSpPr>
         <p:spPr>
           <a:xfrm>
-            <a:off x="6210147" y="3520440"/>
-            <a:ext cx="1920240" cy="457200"/>
+            <a:off x="3535527" y="3200400"/>
+            <a:ext cx="2377440" cy="1554480"/>
           </a:xfrm>
           <a:prstGeom prst="roundRect">
-            <a:avLst>
-              <a:gd name="adj" fmla="val 15000"/>
-            </a:avLst>
+            <a:avLst/>
           </a:prstGeom>
           <a:solidFill>
-            <a:srgbClr val="172033"/>
+            <a:srgbClr val="162134"/>
           </a:solidFill>
           <a:ln>
             <a:noFill/>
@@ -3448,45 +3557,173 @@
           <a:lstStyle/>
           <a:p>
             <a:pPr algn="ctr"/>
-            <a:r>
-              <a:rPr sz="1300" b="1">
-                <a:solidFill>
-                  <a:srgbClr val="FFFFFF"/>
+          </a:p>
+        </p:txBody>
+      </p:sp>
+      <p:sp>
+        <p:nvSpPr>
+          <p:cNvPr id="14" name="TextBox 13"/>
+          <p:cNvSpPr txBox="1"/>
+          <p:nvPr/>
+        </p:nvSpPr>
+        <p:spPr>
+          <a:xfrm>
+            <a:off x="3535527" y="3246120"/>
+            <a:ext cx="2377440" cy="411480"/>
+          </a:xfrm>
+          <a:prstGeom prst="rect">
+            <a:avLst/>
+          </a:prstGeom>
+          <a:noFill/>
+        </p:spPr>
+        <p:txBody>
+          <a:bodyPr wrap="square">
+            <a:spAutoFit/>
+          </a:bodyPr>
+          <a:lstStyle/>
+          <a:p>
+            <a:pPr algn="ctr">
+              <a:defRPr sz="3000" b="0">
+                <a:solidFill>
+                  <a:srgbClr val="F1F5F9"/>
                 </a:solidFill>
                 <a:latin typeface="Calibri"/>
-              </a:rPr>
-              <a:t>Dry</a:t>
-            </a:r>
-            <a:r>
-              <a:rPr sz="1000" b="0">
-                <a:solidFill>
-                  <a:srgbClr val="64748B"/>
+              </a:defRPr>
+            </a:pPr>
+            <a:r>
+              <a:t>🌙</a:t>
+            </a:r>
+          </a:p>
+        </p:txBody>
+      </p:sp>
+      <p:sp>
+        <p:nvSpPr>
+          <p:cNvPr id="15" name="TextBox 14"/>
+          <p:cNvSpPr txBox="1"/>
+          <p:nvPr/>
+        </p:nvSpPr>
+        <p:spPr>
+          <a:xfrm>
+            <a:off x="3535527" y="3657600"/>
+            <a:ext cx="2377440" cy="274320"/>
+          </a:xfrm>
+          <a:prstGeom prst="rect">
+            <a:avLst/>
+          </a:prstGeom>
+          <a:noFill/>
+        </p:spPr>
+        <p:txBody>
+          <a:bodyPr wrap="square">
+            <a:spAutoFit/>
+          </a:bodyPr>
+          <a:lstStyle/>
+          <a:p>
+            <a:pPr algn="ctr">
+              <a:defRPr sz="1400" b="1">
+                <a:solidFill>
+                  <a:srgbClr val="60A5FA"/>
                 </a:solidFill>
                 <a:latin typeface="Calibri"/>
-              </a:rPr>
-              <a:t>  Rain routing</a:t>
-            </a:r>
-          </a:p>
-        </p:txBody>
-      </p:sp>
-      <p:sp>
-        <p:nvSpPr>
-          <p:cNvPr id="9" name="Rounded Rectangle 8"/>
+              </a:defRPr>
+            </a:pPr>
+            <a:r>
+              <a:t>Brightness Map</a:t>
+            </a:r>
+          </a:p>
+        </p:txBody>
+      </p:sp>
+      <p:sp>
+        <p:nvSpPr>
+          <p:cNvPr id="16" name="TextBox 15"/>
+          <p:cNvSpPr txBox="1"/>
+          <p:nvPr/>
+        </p:nvSpPr>
+        <p:spPr>
+          <a:xfrm>
+            <a:off x="3535527" y="3977639"/>
+            <a:ext cx="2377440" cy="411480"/>
+          </a:xfrm>
+          <a:prstGeom prst="rect">
+            <a:avLst/>
+          </a:prstGeom>
+          <a:noFill/>
+        </p:spPr>
+        <p:txBody>
+          <a:bodyPr wrap="square">
+            <a:spAutoFit/>
+          </a:bodyPr>
+          <a:lstStyle/>
+          <a:p>
+            <a:pPr algn="ctr">
+              <a:defRPr sz="1100" b="0">
+                <a:solidFill>
+                  <a:srgbClr val="CBD5E1"/>
+                </a:solidFill>
+                <a:latin typeface="Calibri"/>
+              </a:defRPr>
+            </a:pPr>
+            <a:r>
+              <a:t>Safe from dark</a:t>
+            </a:r>
+            <a:br/>
+            <a:r>
+              <a:t>and isolated streets</a:t>
+            </a:r>
+          </a:p>
+        </p:txBody>
+      </p:sp>
+      <p:sp>
+        <p:nvSpPr>
+          <p:cNvPr id="17" name="TextBox 16"/>
+          <p:cNvSpPr txBox="1"/>
+          <p:nvPr/>
+        </p:nvSpPr>
+        <p:spPr>
+          <a:xfrm>
+            <a:off x="3535527" y="4389120"/>
+            <a:ext cx="2377440" cy="274320"/>
+          </a:xfrm>
+          <a:prstGeom prst="rect">
+            <a:avLst/>
+          </a:prstGeom>
+          <a:noFill/>
+        </p:spPr>
+        <p:txBody>
+          <a:bodyPr wrap="square">
+            <a:spAutoFit/>
+          </a:bodyPr>
+          <a:lstStyle/>
+          <a:p>
+            <a:pPr algn="ctr">
+              <a:defRPr sz="900" b="0">
+                <a:solidFill>
+                  <a:srgbClr val="475569"/>
+                </a:solidFill>
+                <a:latin typeface="Calibri"/>
+              </a:defRPr>
+            </a:pPr>
+            <a:r>
+              <a:t>74K streetlights + businesses</a:t>
+            </a:r>
+          </a:p>
+        </p:txBody>
+      </p:sp>
+      <p:sp>
+        <p:nvSpPr>
+          <p:cNvPr id="18" name="Rounded Rectangle 17"/>
           <p:cNvSpPr/>
           <p:nvPr/>
         </p:nvSpPr>
         <p:spPr>
           <a:xfrm>
-            <a:off x="8358987" y="3520440"/>
-            <a:ext cx="1920240" cy="457200"/>
+            <a:off x="6278727" y="3200400"/>
+            <a:ext cx="2377440" cy="1554480"/>
           </a:xfrm>
           <a:prstGeom prst="roundRect">
-            <a:avLst>
-              <a:gd name="adj" fmla="val 15000"/>
-            </a:avLst>
+            <a:avLst/>
           </a:prstGeom>
           <a:solidFill>
-            <a:srgbClr val="172033"/>
+            <a:srgbClr val="162134"/>
           </a:solidFill>
           <a:ln>
             <a:noFill/>
@@ -3511,37 +3748,19 @@
           <a:lstStyle/>
           <a:p>
             <a:pPr algn="ctr"/>
-            <a:r>
-              <a:rPr sz="1300" b="1">
-                <a:solidFill>
-                  <a:srgbClr val="FFFFFF"/>
-                </a:solidFill>
-                <a:latin typeface="Calibri"/>
-              </a:rPr>
-              <a:t>Grip</a:t>
-            </a:r>
-            <a:r>
-              <a:rPr sz="1000" b="0">
-                <a:solidFill>
-                  <a:srgbClr val="64748B"/>
-                </a:solidFill>
-                <a:latin typeface="Calibri"/>
-              </a:rPr>
-              <a:t>  Ice safety</a:t>
-            </a:r>
-          </a:p>
-        </p:txBody>
-      </p:sp>
-      <p:sp>
-        <p:nvSpPr>
-          <p:cNvPr id="10" name="TextBox 9"/>
+          </a:p>
+        </p:txBody>
+      </p:sp>
+      <p:sp>
+        <p:nvSpPr>
+          <p:cNvPr id="19" name="TextBox 18"/>
           <p:cNvSpPr txBox="1"/>
           <p:nvPr/>
         </p:nvSpPr>
         <p:spPr>
           <a:xfrm>
-            <a:off x="822960" y="4014216"/>
-            <a:ext cx="10545775" cy="228600"/>
+            <a:off x="6278727" y="3246120"/>
+            <a:ext cx="2377440" cy="411480"/>
           </a:xfrm>
           <a:prstGeom prst="rect">
             <a:avLst/>
@@ -3555,37 +3774,147 @@
           <a:lstStyle/>
           <a:p>
             <a:pPr algn="ctr">
-              <a:defRPr sz="900" b="0" i="1">
-                <a:solidFill>
-                  <a:srgbClr val="64748B"/>
+              <a:defRPr sz="3000" b="0">
+                <a:solidFill>
+                  <a:srgbClr val="F1F5F9"/>
                 </a:solidFill>
                 <a:latin typeface="Calibri"/>
               </a:defRPr>
             </a:pPr>
             <a:r>
-              <a:t>auto-switching by time + weather</a:t>
-            </a:r>
-          </a:p>
-        </p:txBody>
-      </p:sp>
-      <p:sp>
-        <p:nvSpPr>
-          <p:cNvPr id="11" name="Rounded Rectangle 10"/>
+              <a:t>🌧️</a:t>
+            </a:r>
+          </a:p>
+        </p:txBody>
+      </p:sp>
+      <p:sp>
+        <p:nvSpPr>
+          <p:cNvPr id="20" name="TextBox 19"/>
+          <p:cNvSpPr txBox="1"/>
+          <p:nvPr/>
+        </p:nvSpPr>
+        <p:spPr>
+          <a:xfrm>
+            <a:off x="6278727" y="3657600"/>
+            <a:ext cx="2377440" cy="274320"/>
+          </a:xfrm>
+          <a:prstGeom prst="rect">
+            <a:avLst/>
+          </a:prstGeom>
+          <a:noFill/>
+        </p:spPr>
+        <p:txBody>
+          <a:bodyPr wrap="square">
+            <a:spAutoFit/>
+          </a:bodyPr>
+          <a:lstStyle/>
+          <a:p>
+            <a:pPr algn="ctr">
+              <a:defRPr sz="1400" b="1">
+                <a:solidFill>
+                  <a:srgbClr val="22D3EE"/>
+                </a:solidFill>
+                <a:latin typeface="Calibri"/>
+              </a:defRPr>
+            </a:pPr>
+            <a:r>
+              <a:t>Flood Overlay</a:t>
+            </a:r>
+          </a:p>
+        </p:txBody>
+      </p:sp>
+      <p:sp>
+        <p:nvSpPr>
+          <p:cNvPr id="21" name="TextBox 20"/>
+          <p:cNvSpPr txBox="1"/>
+          <p:nvPr/>
+        </p:nvSpPr>
+        <p:spPr>
+          <a:xfrm>
+            <a:off x="6278727" y="3977639"/>
+            <a:ext cx="2377440" cy="411480"/>
+          </a:xfrm>
+          <a:prstGeom prst="rect">
+            <a:avLst/>
+          </a:prstGeom>
+          <a:noFill/>
+        </p:spPr>
+        <p:txBody>
+          <a:bodyPr wrap="square">
+            <a:spAutoFit/>
+          </a:bodyPr>
+          <a:lstStyle/>
+          <a:p>
+            <a:pPr algn="ctr">
+              <a:defRPr sz="1100" b="0">
+                <a:solidFill>
+                  <a:srgbClr val="CBD5E1"/>
+                </a:solidFill>
+                <a:latin typeface="Calibri"/>
+              </a:defRPr>
+            </a:pPr>
+            <a:r>
+              <a:t>Safe from</a:t>
+            </a:r>
+            <a:br/>
+            <a:r>
+              <a:t>flooded streets</a:t>
+            </a:r>
+          </a:p>
+        </p:txBody>
+      </p:sp>
+      <p:sp>
+        <p:nvSpPr>
+          <p:cNvPr id="22" name="TextBox 21"/>
+          <p:cNvSpPr txBox="1"/>
+          <p:nvPr/>
+        </p:nvSpPr>
+        <p:spPr>
+          <a:xfrm>
+            <a:off x="6278727" y="4389120"/>
+            <a:ext cx="2377440" cy="274320"/>
+          </a:xfrm>
+          <a:prstGeom prst="rect">
+            <a:avLst/>
+          </a:prstGeom>
+          <a:noFill/>
+        </p:spPr>
+        <p:txBody>
+          <a:bodyPr wrap="square">
+            <a:spAutoFit/>
+          </a:bodyPr>
+          <a:lstStyle/>
+          <a:p>
+            <a:pPr algn="ctr">
+              <a:defRPr sz="900" b="0">
+                <a:solidFill>
+                  <a:srgbClr val="475569"/>
+                </a:solidFill>
+                <a:latin typeface="Calibri"/>
+              </a:defRPr>
+            </a:pPr>
+            <a:r>
+              <a:t>Historical flood areas</a:t>
+            </a:r>
+          </a:p>
+        </p:txBody>
+      </p:sp>
+      <p:sp>
+        <p:nvSpPr>
+          <p:cNvPr id="23" name="Rounded Rectangle 22"/>
           <p:cNvSpPr/>
           <p:nvPr/>
         </p:nvSpPr>
         <p:spPr>
           <a:xfrm>
-            <a:off x="2141067" y="4251960"/>
-            <a:ext cx="1600200" cy="384048"/>
+            <a:off x="9021927" y="3200400"/>
+            <a:ext cx="2377440" cy="1554480"/>
           </a:xfrm>
           <a:prstGeom prst="roundRect">
-            <a:avLst>
-              <a:gd name="adj" fmla="val 15000"/>
-            </a:avLst>
+            <a:avLst/>
           </a:prstGeom>
           <a:solidFill>
-            <a:srgbClr val="5B8C72"/>
+            <a:srgbClr val="162134"/>
           </a:solidFill>
           <a:ln>
             <a:noFill/>
@@ -3606,39 +3935,23 @@
           </a:fontRef>
         </p:style>
         <p:txBody>
-          <a:bodyPr rtlCol="0" anchor="ctr" wrap="square"/>
-          <a:lstStyle/>
-          <a:p>
-            <a:pPr algn="ctr">
-              <a:spcBef>
-                <a:spcPts val="0"/>
-              </a:spcBef>
-              <a:spcAft>
-                <a:spcPts val="0"/>
-              </a:spcAft>
-              <a:defRPr sz="1100" b="0">
-                <a:solidFill>
-                  <a:srgbClr val="FFFFFF"/>
-                </a:solidFill>
-                <a:latin typeface="Calibri"/>
-              </a:defRPr>
-            </a:pPr>
-            <a:r>
-              <a:t>Sun + Buildings</a:t>
-            </a:r>
-          </a:p>
-        </p:txBody>
-      </p:sp>
-      <p:sp>
-        <p:nvSpPr>
-          <p:cNvPr id="12" name="TextBox 11"/>
+          <a:bodyPr rtlCol="0" anchor="ctr"/>
+          <a:lstStyle/>
+          <a:p>
+            <a:pPr algn="ctr"/>
+          </a:p>
+        </p:txBody>
+      </p:sp>
+      <p:sp>
+        <p:nvSpPr>
+          <p:cNvPr id="24" name="TextBox 23"/>
           <p:cNvSpPr txBox="1"/>
           <p:nvPr/>
         </p:nvSpPr>
         <p:spPr>
           <a:xfrm>
-            <a:off x="3814419" y="4334256"/>
-            <a:ext cx="365760" cy="228600"/>
+            <a:off x="9021927" y="3246120"/>
+            <a:ext cx="2377440" cy="411480"/>
           </a:xfrm>
           <a:prstGeom prst="rect">
             <a:avLst/>
@@ -3652,37 +3965,183 @@
           <a:lstStyle/>
           <a:p>
             <a:pPr algn="ctr">
-              <a:defRPr sz="1600" b="0" i="0">
-                <a:solidFill>
-                  <a:srgbClr val="64748B"/>
+              <a:defRPr sz="3000" b="0">
+                <a:solidFill>
+                  <a:srgbClr val="F1F5F9"/>
                 </a:solidFill>
                 <a:latin typeface="Calibri"/>
               </a:defRPr>
             </a:pPr>
             <a:r>
-              <a:t>→</a:t>
-            </a:r>
-          </a:p>
-        </p:txBody>
-      </p:sp>
-      <p:sp>
-        <p:nvSpPr>
-          <p:cNvPr id="13" name="Rounded Rectangle 12"/>
+              <a:t>❄️</a:t>
+            </a:r>
+          </a:p>
+        </p:txBody>
+      </p:sp>
+      <p:sp>
+        <p:nvSpPr>
+          <p:cNvPr id="25" name="TextBox 24"/>
+          <p:cNvSpPr txBox="1"/>
+          <p:nvPr/>
+        </p:nvSpPr>
+        <p:spPr>
+          <a:xfrm>
+            <a:off x="9021927" y="3657600"/>
+            <a:ext cx="2377440" cy="274320"/>
+          </a:xfrm>
+          <a:prstGeom prst="rect">
+            <a:avLst/>
+          </a:prstGeom>
+          <a:noFill/>
+        </p:spPr>
+        <p:txBody>
+          <a:bodyPr wrap="square">
+            <a:spAutoFit/>
+          </a:bodyPr>
+          <a:lstStyle/>
+          <a:p>
+            <a:pPr algn="ctr">
+              <a:defRPr sz="1400" b="1">
+                <a:solidFill>
+                  <a:srgbClr val="F1F5F9"/>
+                </a:solidFill>
+                <a:latin typeface="Calibri"/>
+              </a:defRPr>
+            </a:pPr>
+            <a:r>
+              <a:t>Ice Overlay</a:t>
+            </a:r>
+          </a:p>
+        </p:txBody>
+      </p:sp>
+      <p:sp>
+        <p:nvSpPr>
+          <p:cNvPr id="26" name="TextBox 25"/>
+          <p:cNvSpPr txBox="1"/>
+          <p:nvPr/>
+        </p:nvSpPr>
+        <p:spPr>
+          <a:xfrm>
+            <a:off x="9021927" y="3977639"/>
+            <a:ext cx="2377440" cy="411480"/>
+          </a:xfrm>
+          <a:prstGeom prst="rect">
+            <a:avLst/>
+          </a:prstGeom>
+          <a:noFill/>
+        </p:spPr>
+        <p:txBody>
+          <a:bodyPr wrap="square">
+            <a:spAutoFit/>
+          </a:bodyPr>
+          <a:lstStyle/>
+          <a:p>
+            <a:pPr algn="ctr">
+              <a:defRPr sz="1100" b="0">
+                <a:solidFill>
+                  <a:srgbClr val="CBD5E1"/>
+                </a:solidFill>
+                <a:latin typeface="Calibri"/>
+              </a:defRPr>
+            </a:pPr>
+            <a:r>
+              <a:t>Safe from</a:t>
+            </a:r>
+            <a:br/>
+            <a:r>
+              <a:t>slippery ice</a:t>
+            </a:r>
+          </a:p>
+        </p:txBody>
+      </p:sp>
+      <p:sp>
+        <p:nvSpPr>
+          <p:cNvPr id="27" name="TextBox 26"/>
+          <p:cNvSpPr txBox="1"/>
+          <p:nvPr/>
+        </p:nvSpPr>
+        <p:spPr>
+          <a:xfrm>
+            <a:off x="9021927" y="4389120"/>
+            <a:ext cx="2377440" cy="274320"/>
+          </a:xfrm>
+          <a:prstGeom prst="rect">
+            <a:avLst/>
+          </a:prstGeom>
+          <a:noFill/>
+        </p:spPr>
+        <p:txBody>
+          <a:bodyPr wrap="square">
+            <a:spAutoFit/>
+          </a:bodyPr>
+          <a:lstStyle/>
+          <a:p>
+            <a:pPr algn="ctr">
+              <a:defRPr sz="900" b="0">
+                <a:solidFill>
+                  <a:srgbClr val="475569"/>
+                </a:solidFill>
+                <a:latin typeface="Calibri"/>
+              </a:defRPr>
+            </a:pPr>
+            <a:r>
+              <a:t>Historical icy areas</a:t>
+            </a:r>
+          </a:p>
+        </p:txBody>
+      </p:sp>
+      <p:sp>
+        <p:nvSpPr>
+          <p:cNvPr id="28" name="TextBox 27"/>
+          <p:cNvSpPr txBox="1"/>
+          <p:nvPr/>
+        </p:nvSpPr>
+        <p:spPr>
+          <a:xfrm>
+            <a:off x="731520" y="4983480"/>
+            <a:ext cx="10698480" cy="228600"/>
+          </a:xfrm>
+          <a:prstGeom prst="rect">
+            <a:avLst/>
+          </a:prstGeom>
+          <a:noFill/>
+        </p:spPr>
+        <p:txBody>
+          <a:bodyPr wrap="square">
+            <a:spAutoFit/>
+          </a:bodyPr>
+          <a:lstStyle/>
+          <a:p>
+            <a:pPr algn="ctr">
+              <a:defRPr sz="1200" b="0">
+                <a:solidFill>
+                  <a:srgbClr val="475569"/>
+                </a:solidFill>
+                <a:latin typeface="Calibri"/>
+              </a:defRPr>
+            </a:pPr>
+            <a:r>
+              <a:t>Automatically adapts to current time and weather.</a:t>
+            </a:r>
+          </a:p>
+        </p:txBody>
+      </p:sp>
+      <p:sp>
+        <p:nvSpPr>
+          <p:cNvPr id="29" name="Rectangle 28"/>
           <p:cNvSpPr/>
           <p:nvPr/>
         </p:nvSpPr>
         <p:spPr>
           <a:xfrm>
-            <a:off x="4244187" y="4251960"/>
-            <a:ext cx="1600200" cy="384048"/>
-          </a:xfrm>
-          <a:prstGeom prst="roundRect">
-            <a:avLst>
-              <a:gd name="adj" fmla="val 15000"/>
-            </a:avLst>
+            <a:off x="0" y="5394960"/>
+            <a:ext cx="12191695" cy="1097280"/>
+          </a:xfrm>
+          <a:prstGeom prst="rect">
+            <a:avLst/>
           </a:prstGeom>
           <a:solidFill>
-            <a:srgbClr val="5B8C72"/>
+            <a:srgbClr val="111827"/>
           </a:solidFill>
           <a:ln>
             <a:noFill/>
@@ -3703,39 +4162,23 @@
           </a:fontRef>
         </p:style>
         <p:txBody>
-          <a:bodyPr rtlCol="0" anchor="ctr" wrap="square"/>
-          <a:lstStyle/>
-          <a:p>
-            <a:pPr algn="ctr">
-              <a:spcBef>
-                <a:spcPts val="0"/>
-              </a:spcBef>
-              <a:spcAft>
-                <a:spcPts val="0"/>
-              </a:spcAft>
-              <a:defRPr sz="1100" b="0">
-                <a:solidFill>
-                  <a:srgbClr val="FFFFFF"/>
-                </a:solidFill>
-                <a:latin typeface="Calibri"/>
-              </a:defRPr>
-            </a:pPr>
-            <a:r>
-              <a:t>Shadow Map</a:t>
-            </a:r>
-          </a:p>
-        </p:txBody>
-      </p:sp>
-      <p:sp>
-        <p:nvSpPr>
-          <p:cNvPr id="14" name="TextBox 13"/>
+          <a:bodyPr rtlCol="0" anchor="ctr"/>
+          <a:lstStyle/>
+          <a:p>
+            <a:pPr algn="ctr"/>
+          </a:p>
+        </p:txBody>
+      </p:sp>
+      <p:sp>
+        <p:nvSpPr>
+          <p:cNvPr id="30" name="TextBox 29"/>
           <p:cNvSpPr txBox="1"/>
           <p:nvPr/>
         </p:nvSpPr>
         <p:spPr>
           <a:xfrm>
-            <a:off x="5917539" y="4334256"/>
-            <a:ext cx="365760" cy="228600"/>
+            <a:off x="731520" y="5486400"/>
+            <a:ext cx="5486400" cy="137160"/>
           </a:xfrm>
           <a:prstGeom prst="rect">
             <a:avLst/>
@@ -3748,91 +4191,30 @@
           </a:bodyPr>
           <a:lstStyle/>
           <a:p>
-            <a:pPr algn="ctr">
-              <a:defRPr sz="1600" b="0" i="0">
-                <a:solidFill>
-                  <a:srgbClr val="64748B"/>
+            <a:pPr algn="l">
+              <a:defRPr sz="900" b="1">
+                <a:solidFill>
+                  <a:srgbClr val="4ADE80"/>
                 </a:solidFill>
                 <a:latin typeface="Calibri"/>
               </a:defRPr>
             </a:pPr>
             <a:r>
-              <a:t>→</a:t>
-            </a:r>
-          </a:p>
-        </p:txBody>
-      </p:sp>
-      <p:sp>
-        <p:nvSpPr>
-          <p:cNvPr id="15" name="Rounded Rectangle 14"/>
-          <p:cNvSpPr/>
-          <p:nvPr/>
-        </p:nvSpPr>
-        <p:spPr>
-          <a:xfrm>
-            <a:off x="6347307" y="4251960"/>
-            <a:ext cx="1600200" cy="384048"/>
-          </a:xfrm>
-          <a:prstGeom prst="roundRect">
-            <a:avLst>
-              <a:gd name="adj" fmla="val 15000"/>
-            </a:avLst>
-          </a:prstGeom>
-          <a:solidFill>
-            <a:srgbClr val="5B8C72"/>
-          </a:solidFill>
-          <a:ln>
-            <a:noFill/>
-          </a:ln>
-        </p:spPr>
-        <p:style>
-          <a:lnRef idx="1">
-            <a:schemeClr val="accent1"/>
-          </a:lnRef>
-          <a:fillRef idx="3">
-            <a:schemeClr val="accent1"/>
-          </a:fillRef>
-          <a:effectRef idx="2">
-            <a:schemeClr val="accent1"/>
-          </a:effectRef>
-          <a:fontRef idx="minor">
-            <a:schemeClr val="lt1"/>
-          </a:fontRef>
-        </p:style>
-        <p:txBody>
-          <a:bodyPr rtlCol="0" anchor="ctr" wrap="square"/>
-          <a:lstStyle/>
-          <a:p>
-            <a:pPr algn="ctr">
-              <a:spcBef>
-                <a:spcPts val="0"/>
-              </a:spcBef>
-              <a:spcAft>
-                <a:spcPts val="0"/>
-              </a:spcAft>
-              <a:defRPr sz="1100" b="0">
-                <a:solidFill>
-                  <a:srgbClr val="FFFFFF"/>
-                </a:solidFill>
-                <a:latin typeface="Calibri"/>
-              </a:defRPr>
-            </a:pPr>
-            <a:r>
-              <a:t>Weighted Graph</a:t>
-            </a:r>
-          </a:p>
-        </p:txBody>
-      </p:sp>
-      <p:sp>
-        <p:nvSpPr>
-          <p:cNvPr id="16" name="TextBox 15"/>
+              <a:t>VERIFIED DATA</a:t>
+            </a:r>
+          </a:p>
+        </p:txBody>
+      </p:sp>
+      <p:sp>
+        <p:nvSpPr>
+          <p:cNvPr id="31" name="TextBox 30"/>
           <p:cNvSpPr txBox="1"/>
           <p:nvPr/>
         </p:nvSpPr>
         <p:spPr>
           <a:xfrm>
-            <a:off x="8020659" y="4334256"/>
-            <a:ext cx="365760" cy="228600"/>
+            <a:off x="731520" y="5669280"/>
+            <a:ext cx="5486400" cy="365760"/>
           </a:xfrm>
           <a:prstGeom prst="rect">
             <a:avLst/>
@@ -3845,91 +4227,34 @@
           </a:bodyPr>
           <a:lstStyle/>
           <a:p>
-            <a:pPr algn="ctr">
-              <a:defRPr sz="1600" b="0" i="0">
-                <a:solidFill>
-                  <a:srgbClr val="64748B"/>
+            <a:pPr algn="l">
+              <a:defRPr sz="1000" b="0">
+                <a:solidFill>
+                  <a:srgbClr val="94A3B8"/>
                 </a:solidFill>
                 <a:latin typeface="Calibri"/>
               </a:defRPr>
             </a:pPr>
             <a:r>
-              <a:t>→</a:t>
-            </a:r>
-          </a:p>
-        </p:txBody>
-      </p:sp>
-      <p:sp>
-        <p:nvSpPr>
-          <p:cNvPr id="17" name="Rounded Rectangle 16"/>
-          <p:cNvSpPr/>
-          <p:nvPr/>
-        </p:nvSpPr>
-        <p:spPr>
-          <a:xfrm>
-            <a:off x="8450427" y="4251960"/>
-            <a:ext cx="1600200" cy="384048"/>
-          </a:xfrm>
-          <a:prstGeom prst="roundRect">
-            <a:avLst>
-              <a:gd name="adj" fmla="val 15000"/>
-            </a:avLst>
-          </a:prstGeom>
-          <a:solidFill>
-            <a:srgbClr val="D9972B"/>
-          </a:solidFill>
-          <a:ln>
-            <a:noFill/>
-          </a:ln>
-        </p:spPr>
-        <p:style>
-          <a:lnRef idx="1">
-            <a:schemeClr val="accent1"/>
-          </a:lnRef>
-          <a:fillRef idx="3">
-            <a:schemeClr val="accent1"/>
-          </a:fillRef>
-          <a:effectRef idx="2">
-            <a:schemeClr val="accent1"/>
-          </a:effectRef>
-          <a:fontRef idx="minor">
-            <a:schemeClr val="lt1"/>
-          </a:fontRef>
-        </p:style>
-        <p:txBody>
-          <a:bodyPr rtlCol="0" anchor="ctr" wrap="square"/>
-          <a:lstStyle/>
-          <a:p>
-            <a:pPr algn="ctr">
-              <a:spcBef>
-                <a:spcPts val="0"/>
-              </a:spcBef>
-              <a:spcAft>
-                <a:spcPts val="0"/>
-              </a:spcAft>
-              <a:defRPr sz="1100" b="1">
-                <a:solidFill>
-                  <a:srgbClr val="0F172A"/>
-                </a:solidFill>
-                <a:latin typeface="Calibri"/>
-              </a:defRPr>
-            </a:pPr>
-            <a:r>
-              <a:t>Safe Route</a:t>
-            </a:r>
-          </a:p>
-        </p:txBody>
-      </p:sp>
-      <p:sp>
-        <p:nvSpPr>
-          <p:cNvPr id="18" name="TextBox 17"/>
+              <a:t>128K buildings with height  ·  74K streetlights  ·  citywide tree canopy</a:t>
+            </a:r>
+            <a:br/>
+            <a:r>
+              <a:t>257K+ crime records  ·  42K+ crash records  ·  free real-time APIs</a:t>
+            </a:r>
+          </a:p>
+        </p:txBody>
+      </p:sp>
+      <p:sp>
+        <p:nvSpPr>
+          <p:cNvPr id="32" name="TextBox 31"/>
           <p:cNvSpPr txBox="1"/>
           <p:nvPr/>
         </p:nvSpPr>
         <p:spPr>
           <a:xfrm>
-            <a:off x="822960" y="4672584"/>
-            <a:ext cx="10545775" cy="228600"/>
+            <a:off x="6858000" y="5486400"/>
+            <a:ext cx="4754880" cy="137160"/>
           </a:xfrm>
           <a:prstGeom prst="rect">
             <a:avLst/>
@@ -3942,30 +4267,30 @@
           </a:bodyPr>
           <a:lstStyle/>
           <a:p>
-            <a:pPr algn="ctr">
-              <a:defRPr sz="900" b="0" i="1">
-                <a:solidFill>
-                  <a:srgbClr val="64748B"/>
+            <a:pPr algn="l">
+              <a:defRPr sz="900" b="1">
+                <a:solidFill>
+                  <a:srgbClr val="4ADE80"/>
                 </a:solidFill>
                 <a:latin typeface="Calibri"/>
               </a:defRPr>
             </a:pPr>
             <a:r>
-              <a:t>+ streetlights, trees, crime, crash data layers</a:t>
-            </a:r>
-          </a:p>
-        </p:txBody>
-      </p:sp>
-      <p:sp>
-        <p:nvSpPr>
-          <p:cNvPr id="19" name="TextBox 18"/>
+              <a:t>SHADOW MATH</a:t>
+            </a:r>
+          </a:p>
+        </p:txBody>
+      </p:sp>
+      <p:sp>
+        <p:nvSpPr>
+          <p:cNvPr id="33" name="TextBox 32"/>
           <p:cNvSpPr txBox="1"/>
           <p:nvPr/>
         </p:nvSpPr>
         <p:spPr>
           <a:xfrm>
-            <a:off x="822960" y="5074920"/>
-            <a:ext cx="10545775" cy="274320"/>
+            <a:off x="6858000" y="5669280"/>
+            <a:ext cx="4754880" cy="365760"/>
           </a:xfrm>
           <a:prstGeom prst="rect">
             <a:avLst/>
@@ -3978,8 +4303,8 @@
           </a:bodyPr>
           <a:lstStyle/>
           <a:p>
-            <a:pPr algn="ctr">
-              <a:defRPr sz="1000" b="0" i="0">
+            <a:pPr algn="l">
+              <a:defRPr sz="1000" b="0">
                 <a:solidFill>
                   <a:srgbClr val="94A3B8"/>
                 </a:solidFill>
@@ -3987,21 +4312,25 @@
               </a:defRPr>
             </a:pPr>
             <a:r>
-              <a:t>128K buildings  │  74K streetlights  │  257K+ incidents  │  real-time UV / AQI / weather</a:t>
-            </a:r>
-          </a:p>
-        </p:txBody>
-      </p:sp>
-      <p:sp>
-        <p:nvSpPr>
-          <p:cNvPr id="20" name="TextBox 19"/>
+              <a:t>Summer 2pm: 10m building → 5m shadow</a:t>
+            </a:r>
+            <a:br/>
+            <a:r>
+              <a:t>Winter 2pm: 10m building → 27m shadow (5× longer)</a:t>
+            </a:r>
+          </a:p>
+        </p:txBody>
+      </p:sp>
+      <p:sp>
+        <p:nvSpPr>
+          <p:cNvPr id="34" name="TextBox 33"/>
           <p:cNvSpPr txBox="1"/>
           <p:nvPr/>
         </p:nvSpPr>
         <p:spPr>
           <a:xfrm>
-            <a:off x="822960" y="5532120"/>
-            <a:ext cx="10545775" cy="228600"/>
+            <a:off x="731520" y="6172200"/>
+            <a:ext cx="10698480" cy="182880"/>
           </a:xfrm>
           <a:prstGeom prst="rect">
             <a:avLst/>
@@ -4015,29 +4344,29 @@
           <a:lstStyle/>
           <a:p>
             <a:pPr algn="ctr">
-              <a:defRPr sz="900" b="0" i="1">
-                <a:solidFill>
-                  <a:srgbClr val="64748B"/>
+              <a:defRPr sz="1000" b="0">
+                <a:solidFill>
+                  <a:srgbClr val="475569"/>
                 </a:solidFill>
                 <a:latin typeface="Calibri"/>
               </a:defRPr>
             </a:pPr>
             <a:r>
-              <a:t>Says "I don't know" when data is insufficient</a:t>
-            </a:r>
-          </a:p>
-        </p:txBody>
-      </p:sp>
-      <p:sp>
-        <p:nvSpPr>
-          <p:cNvPr id="21" name="TextBox 20"/>
+              <a:t>In the light of day, we shield you from the sun. In the dark of night, we guide you to the light.</a:t>
+            </a:r>
+          </a:p>
+        </p:txBody>
+      </p:sp>
+      <p:sp>
+        <p:nvSpPr>
+          <p:cNvPr id="35" name="TextBox 34"/>
           <p:cNvSpPr txBox="1"/>
           <p:nvPr/>
         </p:nvSpPr>
         <p:spPr>
           <a:xfrm>
-            <a:off x="1645920" y="6035040"/>
-            <a:ext cx="8869680" cy="411480"/>
+            <a:off x="731520" y="6492240"/>
+            <a:ext cx="4572000" cy="182880"/>
           </a:xfrm>
           <a:prstGeom prst="rect">
             <a:avLst/>
@@ -4050,16 +4379,52 @@
           </a:bodyPr>
           <a:lstStyle/>
           <a:p>
-            <a:pPr algn="ctr">
-              <a:defRPr sz="1100" b="0" i="1">
-                <a:solidFill>
-                  <a:srgbClr val="64748B"/>
+            <a:pPr algn="l">
+              <a:defRPr sz="800" b="0">
+                <a:solidFill>
+                  <a:srgbClr val="475569"/>
                 </a:solidFill>
                 <a:latin typeface="Calibri"/>
               </a:defRPr>
             </a:pPr>
             <a:r>
-              <a:t>In the light of day, we shield you from the sun.  In the dark of night, we guide you to the light.</a:t>
+              <a:t>City of Boston  ·  Python  ·  pvlib  ·  GeoPandas  ·  Leaflet</a:t>
+            </a:r>
+          </a:p>
+        </p:txBody>
+      </p:sp>
+      <p:sp>
+        <p:nvSpPr>
+          <p:cNvPr id="36" name="TextBox 35"/>
+          <p:cNvSpPr txBox="1"/>
+          <p:nvPr/>
+        </p:nvSpPr>
+        <p:spPr>
+          <a:xfrm>
+            <a:off x="6858000" y="6492240"/>
+            <a:ext cx="4754880" cy="182880"/>
+          </a:xfrm>
+          <a:prstGeom prst="rect">
+            <a:avLst/>
+          </a:prstGeom>
+          <a:noFill/>
+        </p:spPr>
+        <p:txBody>
+          <a:bodyPr wrap="square">
+            <a:spAutoFit/>
+          </a:bodyPr>
+          <a:lstStyle/>
+          <a:p>
+            <a:pPr algn="r">
+              <a:defRPr sz="800" b="0">
+                <a:solidFill>
+                  <a:srgbClr val="475569"/>
+                </a:solidFill>
+                <a:latin typeface="Calibri"/>
+              </a:defRPr>
+            </a:pPr>
+            <a:r>
+              <a:t>MIT 1.001 — Engineering Computation and Data Science</a:t>
             </a:r>
           </a:p>
         </p:txBody>

</xml_diff>